<commit_message>
Grafiken luftiger gestalten und Fahrplan auf 6 Wochen erweitern
- Diagramme mit mehr Weissraum/besseren Proportionen neu gerendert
- Zeitstrahl von 4 auf 6 Wochen erweitert (inkl. Mockup-Test & Pilot-Anbahnung)
- PowerPoint-Folie und Markdown-Dokumente entsprechend aktualisiert

Co-Authored-By: Claude Opus 4.8 <noreply@anthropic.com>
Claude-Session: https://claude.ai/code/session_019FgPBqXjiPh7zUu2dWogTW
</commit_message>
<xml_diff>
--- a/Audio-KI-OP-Praesentation.pptx
+++ b/Audio-KI-OP-Praesentation.pptx
@@ -16474,8 +16474,8 @@
         </p:blipFill>
         <p:spPr>
           <a:xfrm>
-            <a:off x="606286" y="2468880"/>
-            <a:ext cx="7931426" cy="1920240"/>
+            <a:off x="383189" y="2331720"/>
+            <a:ext cx="8377621" cy="2103120"/>
           </a:xfrm>
           <a:prstGeom prst="rect">
             <a:avLst/>
@@ -16788,8 +16788,8 @@
         </p:blipFill>
         <p:spPr>
           <a:xfrm>
-            <a:off x="1828800" y="1600200"/>
-            <a:ext cx="5486400" cy="2744913"/>
+            <a:off x="1783080" y="1554480"/>
+            <a:ext cx="5577840" cy="2941696"/>
           </a:xfrm>
           <a:prstGeom prst="rect">
             <a:avLst/>
@@ -18088,8 +18088,8 @@
         </p:blipFill>
         <p:spPr>
           <a:xfrm>
-            <a:off x="1394226" y="1554480"/>
-            <a:ext cx="6355547" cy="3108960"/>
+            <a:off x="1563266" y="1481328"/>
+            <a:ext cx="6017467" cy="3154680"/>
           </a:xfrm>
           <a:prstGeom prst="rect">
             <a:avLst/>
@@ -18979,7 +18979,7 @@
                 </a:solidFill>
                 <a:latin typeface="Calibri Light"/>
               </a:rPr>
-              <a:t>Mein Plan: 4 Wochen</a:t>
+              <a:t>Mein Plan: 6 Wochen</a:t>
             </a:r>
           </a:p>
         </p:txBody>
@@ -19044,8 +19044,8 @@
         </p:blipFill>
         <p:spPr>
           <a:xfrm>
-            <a:off x="1133668" y="1554480"/>
-            <a:ext cx="6876663" cy="2651760"/>
+            <a:off x="1346806" y="1481328"/>
+            <a:ext cx="6450387" cy="3063240"/>
           </a:xfrm>
           <a:prstGeom prst="rect">
             <a:avLst/>
@@ -19060,8 +19060,8 @@
         </p:nvSpPr>
         <p:spPr>
           <a:xfrm>
-            <a:off x="548640" y="4343400"/>
-            <a:ext cx="8046720" cy="365760"/>
+            <a:off x="548640" y="4590288"/>
+            <a:ext cx="8046720" cy="274320"/>
           </a:xfrm>
           <a:prstGeom prst="rect">
             <a:avLst/>
@@ -19076,13 +19076,13 @@
           <a:p>
             <a:pPr algn="l"/>
             <a:r>
-              <a:rPr sz="1300" b="1">
+              <a:rPr sz="1200" b="1">
                 <a:solidFill>
                   <a:srgbClr val="556D96"/>
                 </a:solidFill>
                 <a:latin typeface="Calibri"/>
               </a:rPr>
-              <a:t>Ich spreche mit ~5 Kliniken und liefere eine klare Go/No-Go-Empfehlung mit Zahlen.</a:t>
+              <a:t>Mehrere Klinik-Gespräche, Recht &amp; erste Pilot-Anbahnung – danach klare Go/No-Go-Empfehlung mit Zahlen.</a:t>
             </a:r>
           </a:p>
         </p:txBody>
@@ -19393,8 +19393,8 @@
         </p:blipFill>
         <p:spPr>
           <a:xfrm>
-            <a:off x="2057400" y="1508760"/>
-            <a:ext cx="5029200" cy="2351241"/>
+            <a:off x="2011680" y="1463040"/>
+            <a:ext cx="5120640" cy="2872055"/>
           </a:xfrm>
           <a:prstGeom prst="rect">
             <a:avLst/>
@@ -19513,7 +19513,7 @@
                 </a:solidFill>
                 <a:latin typeface="Calibri"/>
               </a:rPr>
-              <a:t>• Zeit:  ~4 Wochen</a:t>
+              <a:t>• Zeit:  ~6 Wochen</a:t>
             </a:r>
           </a:p>
           <a:p>
@@ -19593,7 +19593,7 @@
                 </a:solidFill>
                 <a:latin typeface="Calibri"/>
               </a:rPr>
-              <a:t>„Gebt mir 4 Wochen, dann</a:t>
+              <a:t>„Gebt mir 6 Wochen, dann</a:t>
             </a:r>
           </a:p>
           <a:p>

</xml_diff>